<commit_message>
Update Module 6 to 'Research' and remove Module 8
Revamps Module 6 materials to focus on Document Processing and Research (instructor changed to Wes), updating lesson scripts, slide outlines, and the module intro to reflect a Deep Research → Notebook LM → AI Slides pipeline and new lesson names/activities. Removes Module 8 lesson and intro files and associated slide assets, and renames/moves a couple of PPTX decks from module-8 into module-6 (with several obsolete module-6/module-8 pptx files deleted). Also updates slides README to reflect the new deck names and adjusts slides content for module-6; regenerator script (scripts/generate-slide-decks.py) was modified accordingly. A temporary ~$ PPTX file was added by the editor.
</commit_message>
<xml_diff>
--- a/docs/video-scripts/slides/pptx/module-4/lesson-4-3-data-cleanup.pptx
+++ b/docs/video-scripts/slides/pptx/module-4/lesson-4-3-data-cleanup.pptx
@@ -5,12 +5,13 @@
     <p:sldMasterId id="2147483648" r:id="rId1"/>
   </p:sldMasterIdLst>
   <p:sldIdLst>
-    <p:sldId id="256" r:id="rId2"/>
-    <p:sldId id="257" r:id="rId3"/>
-    <p:sldId id="258" r:id="rId4"/>
-    <p:sldId id="259" r:id="rId5"/>
+    <p:sldId id="256" r:id="rId7"/>
+    <p:sldId id="257" r:id="rId8"/>
+    <p:sldId id="258" r:id="rId9"/>
+    <p:sldId id="259" r:id="rId10"/>
+    <p:sldId id="260" r:id="rId11"/>
   </p:sldIdLst>
-  <p:sldSz cx="14630400" cy="8229600"/>
+  <p:sldSz cx="14630400" cy="8229600" type="screen4x3"/>
   <p:notesSz cx="6858000" cy="9144000"/>
   <p:defaultTextStyle>
     <a:defPPr>
@@ -107,22 +108,6 @@
       </a:defRPr>
     </a:lvl9pPr>
   </p:defaultTextStyle>
-  <p:extLst>
-    <p:ext uri="{EFAFB233-063F-42B5-8137-9DF3F51BA10A}">
-      <p15:sldGuideLst xmlns:p15="http://schemas.microsoft.com/office/powerpoint/2012/main">
-        <p15:guide id="1" orient="horz" pos="2160">
-          <p15:clr>
-            <a:srgbClr val="A4A3A4"/>
-          </p15:clr>
-        </p15:guide>
-        <p15:guide id="2" pos="2880">
-          <p15:clr>
-            <a:srgbClr val="A4A3A4"/>
-          </p15:clr>
-        </p15:guide>
-      </p15:sldGuideLst>
-    </p:ext>
-  </p:extLst>
 </p:presentation>
 </file>
 
@@ -164,9 +149,10 @@
           <a:lstStyle/>
           <a:p>
             <a:r>
-              <a:rPr lang="en-US"/>
+              <a:rPr lang="en-US" smtClean="0"/>
               <a:t>Click to edit Master title style</a:t>
             </a:r>
+            <a:endParaRPr lang="en-US"/>
           </a:p>
         </p:txBody>
       </p:sp>
@@ -282,9 +268,10 @@
           </a:lstStyle>
           <a:p>
             <a:r>
-              <a:rPr lang="en-US"/>
+              <a:rPr lang="en-US" smtClean="0"/>
               <a:t>Click to edit Master subtitle style</a:t>
             </a:r>
+            <a:endParaRPr lang="en-US"/>
           </a:p>
         </p:txBody>
       </p:sp>
@@ -305,7 +292,7 @@
           <a:p>
             <a:fld id="{5BCAD085-E8A6-8845-BD4E-CB4CCA059FC4}" type="datetimeFigureOut">
               <a:rPr lang="en-US" smtClean="0"/>
-              <a:t>5/4/26</a:t>
+              <a:t>1/27/13</a:t>
             </a:fld>
             <a:endParaRPr lang="en-US"/>
           </a:p>
@@ -399,9 +386,10 @@
           <a:lstStyle/>
           <a:p>
             <a:r>
-              <a:rPr lang="en-US"/>
+              <a:rPr lang="en-US" smtClean="0"/>
               <a:t>Click to edit Master title style</a:t>
             </a:r>
+            <a:endParaRPr lang="en-US"/>
           </a:p>
         </p:txBody>
       </p:sp>
@@ -422,37 +410,38 @@
           <a:p>
             <a:pPr lvl="0"/>
             <a:r>
-              <a:rPr lang="en-US"/>
+              <a:rPr lang="en-US" smtClean="0"/>
               <a:t>Click to edit Master text styles</a:t>
             </a:r>
           </a:p>
           <a:p>
             <a:pPr lvl="1"/>
             <a:r>
-              <a:rPr lang="en-US"/>
+              <a:rPr lang="en-US" smtClean="0"/>
               <a:t>Second level</a:t>
             </a:r>
           </a:p>
           <a:p>
             <a:pPr lvl="2"/>
             <a:r>
-              <a:rPr lang="en-US"/>
+              <a:rPr lang="en-US" smtClean="0"/>
               <a:t>Third level</a:t>
             </a:r>
           </a:p>
           <a:p>
             <a:pPr lvl="3"/>
             <a:r>
-              <a:rPr lang="en-US"/>
+              <a:rPr lang="en-US" smtClean="0"/>
               <a:t>Fourth level</a:t>
             </a:r>
           </a:p>
           <a:p>
             <a:pPr lvl="4"/>
             <a:r>
-              <a:rPr lang="en-US"/>
+              <a:rPr lang="en-US" smtClean="0"/>
               <a:t>Fifth level</a:t>
             </a:r>
+            <a:endParaRPr lang="en-US"/>
           </a:p>
         </p:txBody>
       </p:sp>
@@ -473,7 +462,7 @@
           <a:p>
             <a:fld id="{5BCAD085-E8A6-8845-BD4E-CB4CCA059FC4}" type="datetimeFigureOut">
               <a:rPr lang="en-US" smtClean="0"/>
-              <a:t>5/4/26</a:t>
+              <a:t>1/27/13</a:t>
             </a:fld>
             <a:endParaRPr lang="en-US"/>
           </a:p>
@@ -572,9 +561,10 @@
           <a:lstStyle/>
           <a:p>
             <a:r>
-              <a:rPr lang="en-US"/>
+              <a:rPr lang="en-US" smtClean="0"/>
               <a:t>Click to edit Master title style</a:t>
             </a:r>
+            <a:endParaRPr lang="en-US"/>
           </a:p>
         </p:txBody>
       </p:sp>
@@ -600,37 +590,38 @@
           <a:p>
             <a:pPr lvl="0"/>
             <a:r>
-              <a:rPr lang="en-US"/>
+              <a:rPr lang="en-US" smtClean="0"/>
               <a:t>Click to edit Master text styles</a:t>
             </a:r>
           </a:p>
           <a:p>
             <a:pPr lvl="1"/>
             <a:r>
-              <a:rPr lang="en-US"/>
+              <a:rPr lang="en-US" smtClean="0"/>
               <a:t>Second level</a:t>
             </a:r>
           </a:p>
           <a:p>
             <a:pPr lvl="2"/>
             <a:r>
-              <a:rPr lang="en-US"/>
+              <a:rPr lang="en-US" smtClean="0"/>
               <a:t>Third level</a:t>
             </a:r>
           </a:p>
           <a:p>
             <a:pPr lvl="3"/>
             <a:r>
-              <a:rPr lang="en-US"/>
+              <a:rPr lang="en-US" smtClean="0"/>
               <a:t>Fourth level</a:t>
             </a:r>
           </a:p>
           <a:p>
             <a:pPr lvl="4"/>
             <a:r>
-              <a:rPr lang="en-US"/>
+              <a:rPr lang="en-US" smtClean="0"/>
               <a:t>Fifth level</a:t>
             </a:r>
+            <a:endParaRPr lang="en-US"/>
           </a:p>
         </p:txBody>
       </p:sp>
@@ -651,7 +642,7 @@
           <a:p>
             <a:fld id="{5BCAD085-E8A6-8845-BD4E-CB4CCA059FC4}" type="datetimeFigureOut">
               <a:rPr lang="en-US" smtClean="0"/>
-              <a:t>5/4/26</a:t>
+              <a:t>1/27/13</a:t>
             </a:fld>
             <a:endParaRPr lang="en-US"/>
           </a:p>
@@ -745,9 +736,10 @@
           <a:lstStyle/>
           <a:p>
             <a:r>
-              <a:rPr lang="en-US"/>
+              <a:rPr lang="en-US" smtClean="0"/>
               <a:t>Click to edit Master title style</a:t>
             </a:r>
+            <a:endParaRPr lang="en-US"/>
           </a:p>
         </p:txBody>
       </p:sp>
@@ -768,37 +760,38 @@
           <a:p>
             <a:pPr lvl="0"/>
             <a:r>
-              <a:rPr lang="en-US"/>
+              <a:rPr lang="en-US" smtClean="0"/>
               <a:t>Click to edit Master text styles</a:t>
             </a:r>
           </a:p>
           <a:p>
             <a:pPr lvl="1"/>
             <a:r>
-              <a:rPr lang="en-US"/>
+              <a:rPr lang="en-US" smtClean="0"/>
               <a:t>Second level</a:t>
             </a:r>
           </a:p>
           <a:p>
             <a:pPr lvl="2"/>
             <a:r>
-              <a:rPr lang="en-US"/>
+              <a:rPr lang="en-US" smtClean="0"/>
               <a:t>Third level</a:t>
             </a:r>
           </a:p>
           <a:p>
             <a:pPr lvl="3"/>
             <a:r>
-              <a:rPr lang="en-US"/>
+              <a:rPr lang="en-US" smtClean="0"/>
               <a:t>Fourth level</a:t>
             </a:r>
           </a:p>
           <a:p>
             <a:pPr lvl="4"/>
             <a:r>
-              <a:rPr lang="en-US"/>
+              <a:rPr lang="en-US" smtClean="0"/>
               <a:t>Fifth level</a:t>
             </a:r>
+            <a:endParaRPr lang="en-US"/>
           </a:p>
         </p:txBody>
       </p:sp>
@@ -819,7 +812,7 @@
           <a:p>
             <a:fld id="{5BCAD085-E8A6-8845-BD4E-CB4CCA059FC4}" type="datetimeFigureOut">
               <a:rPr lang="en-US" smtClean="0"/>
-              <a:t>5/4/26</a:t>
+              <a:t>1/27/13</a:t>
             </a:fld>
             <a:endParaRPr lang="en-US"/>
           </a:p>
@@ -922,9 +915,10 @@
           </a:lstStyle>
           <a:p>
             <a:r>
-              <a:rPr lang="en-US"/>
+              <a:rPr lang="en-US" smtClean="0"/>
               <a:t>Click to edit Master title style</a:t>
             </a:r>
+            <a:endParaRPr lang="en-US"/>
           </a:p>
         </p:txBody>
       </p:sp>
@@ -1041,7 +1035,7 @@
           <a:p>
             <a:pPr lvl="0"/>
             <a:r>
-              <a:rPr lang="en-US"/>
+              <a:rPr lang="en-US" smtClean="0"/>
               <a:t>Click to edit Master text styles</a:t>
             </a:r>
           </a:p>
@@ -1064,7 +1058,7 @@
           <a:p>
             <a:fld id="{5BCAD085-E8A6-8845-BD4E-CB4CCA059FC4}" type="datetimeFigureOut">
               <a:rPr lang="en-US" smtClean="0"/>
-              <a:t>5/4/26</a:t>
+              <a:t>1/27/13</a:t>
             </a:fld>
             <a:endParaRPr lang="en-US"/>
           </a:p>
@@ -1158,9 +1152,10 @@
           <a:lstStyle/>
           <a:p>
             <a:r>
-              <a:rPr lang="en-US"/>
+              <a:rPr lang="en-US" smtClean="0"/>
               <a:t>Click to edit Master title style</a:t>
             </a:r>
+            <a:endParaRPr lang="en-US"/>
           </a:p>
         </p:txBody>
       </p:sp>
@@ -1214,37 +1209,38 @@
           <a:p>
             <a:pPr lvl="0"/>
             <a:r>
-              <a:rPr lang="en-US"/>
+              <a:rPr lang="en-US" smtClean="0"/>
               <a:t>Click to edit Master text styles</a:t>
             </a:r>
           </a:p>
           <a:p>
             <a:pPr lvl="1"/>
             <a:r>
-              <a:rPr lang="en-US"/>
+              <a:rPr lang="en-US" smtClean="0"/>
               <a:t>Second level</a:t>
             </a:r>
           </a:p>
           <a:p>
             <a:pPr lvl="2"/>
             <a:r>
-              <a:rPr lang="en-US"/>
+              <a:rPr lang="en-US" smtClean="0"/>
               <a:t>Third level</a:t>
             </a:r>
           </a:p>
           <a:p>
             <a:pPr lvl="3"/>
             <a:r>
-              <a:rPr lang="en-US"/>
+              <a:rPr lang="en-US" smtClean="0"/>
               <a:t>Fourth level</a:t>
             </a:r>
           </a:p>
           <a:p>
             <a:pPr lvl="4"/>
             <a:r>
-              <a:rPr lang="en-US"/>
+              <a:rPr lang="en-US" smtClean="0"/>
               <a:t>Fifth level</a:t>
             </a:r>
+            <a:endParaRPr lang="en-US"/>
           </a:p>
         </p:txBody>
       </p:sp>
@@ -1298,37 +1294,38 @@
           <a:p>
             <a:pPr lvl="0"/>
             <a:r>
-              <a:rPr lang="en-US"/>
+              <a:rPr lang="en-US" smtClean="0"/>
               <a:t>Click to edit Master text styles</a:t>
             </a:r>
           </a:p>
           <a:p>
             <a:pPr lvl="1"/>
             <a:r>
-              <a:rPr lang="en-US"/>
+              <a:rPr lang="en-US" smtClean="0"/>
               <a:t>Second level</a:t>
             </a:r>
           </a:p>
           <a:p>
             <a:pPr lvl="2"/>
             <a:r>
-              <a:rPr lang="en-US"/>
+              <a:rPr lang="en-US" smtClean="0"/>
               <a:t>Third level</a:t>
             </a:r>
           </a:p>
           <a:p>
             <a:pPr lvl="3"/>
             <a:r>
-              <a:rPr lang="en-US"/>
+              <a:rPr lang="en-US" smtClean="0"/>
               <a:t>Fourth level</a:t>
             </a:r>
           </a:p>
           <a:p>
             <a:pPr lvl="4"/>
             <a:r>
-              <a:rPr lang="en-US"/>
+              <a:rPr lang="en-US" smtClean="0"/>
               <a:t>Fifth level</a:t>
             </a:r>
+            <a:endParaRPr lang="en-US"/>
           </a:p>
         </p:txBody>
       </p:sp>
@@ -1349,7 +1346,7 @@
           <a:p>
             <a:fld id="{5BCAD085-E8A6-8845-BD4E-CB4CCA059FC4}" type="datetimeFigureOut">
               <a:rPr lang="en-US" smtClean="0"/>
-              <a:t>5/4/26</a:t>
+              <a:t>1/27/13</a:t>
             </a:fld>
             <a:endParaRPr lang="en-US"/>
           </a:p>
@@ -1447,9 +1444,10 @@
           </a:lstStyle>
           <a:p>
             <a:r>
-              <a:rPr lang="en-US"/>
+              <a:rPr lang="en-US" smtClean="0"/>
               <a:t>Click to edit Master title style</a:t>
             </a:r>
+            <a:endParaRPr lang="en-US"/>
           </a:p>
         </p:txBody>
       </p:sp>
@@ -1512,7 +1510,7 @@
           <a:p>
             <a:pPr lvl="0"/>
             <a:r>
-              <a:rPr lang="en-US"/>
+              <a:rPr lang="en-US" smtClean="0"/>
               <a:t>Click to edit Master text styles</a:t>
             </a:r>
           </a:p>
@@ -1568,37 +1566,38 @@
           <a:p>
             <a:pPr lvl="0"/>
             <a:r>
-              <a:rPr lang="en-US"/>
+              <a:rPr lang="en-US" smtClean="0"/>
               <a:t>Click to edit Master text styles</a:t>
             </a:r>
           </a:p>
           <a:p>
             <a:pPr lvl="1"/>
             <a:r>
-              <a:rPr lang="en-US"/>
+              <a:rPr lang="en-US" smtClean="0"/>
               <a:t>Second level</a:t>
             </a:r>
           </a:p>
           <a:p>
             <a:pPr lvl="2"/>
             <a:r>
-              <a:rPr lang="en-US"/>
+              <a:rPr lang="en-US" smtClean="0"/>
               <a:t>Third level</a:t>
             </a:r>
           </a:p>
           <a:p>
             <a:pPr lvl="3"/>
             <a:r>
-              <a:rPr lang="en-US"/>
+              <a:rPr lang="en-US" smtClean="0"/>
               <a:t>Fourth level</a:t>
             </a:r>
           </a:p>
           <a:p>
             <a:pPr lvl="4"/>
             <a:r>
-              <a:rPr lang="en-US"/>
+              <a:rPr lang="en-US" smtClean="0"/>
               <a:t>Fifth level</a:t>
             </a:r>
+            <a:endParaRPr lang="en-US"/>
           </a:p>
         </p:txBody>
       </p:sp>
@@ -1661,7 +1660,7 @@
           <a:p>
             <a:pPr lvl="0"/>
             <a:r>
-              <a:rPr lang="en-US"/>
+              <a:rPr lang="en-US" smtClean="0"/>
               <a:t>Click to edit Master text styles</a:t>
             </a:r>
           </a:p>
@@ -1717,37 +1716,38 @@
           <a:p>
             <a:pPr lvl="0"/>
             <a:r>
-              <a:rPr lang="en-US"/>
+              <a:rPr lang="en-US" smtClean="0"/>
               <a:t>Click to edit Master text styles</a:t>
             </a:r>
           </a:p>
           <a:p>
             <a:pPr lvl="1"/>
             <a:r>
-              <a:rPr lang="en-US"/>
+              <a:rPr lang="en-US" smtClean="0"/>
               <a:t>Second level</a:t>
             </a:r>
           </a:p>
           <a:p>
             <a:pPr lvl="2"/>
             <a:r>
-              <a:rPr lang="en-US"/>
+              <a:rPr lang="en-US" smtClean="0"/>
               <a:t>Third level</a:t>
             </a:r>
           </a:p>
           <a:p>
             <a:pPr lvl="3"/>
             <a:r>
-              <a:rPr lang="en-US"/>
+              <a:rPr lang="en-US" smtClean="0"/>
               <a:t>Fourth level</a:t>
             </a:r>
           </a:p>
           <a:p>
             <a:pPr lvl="4"/>
             <a:r>
-              <a:rPr lang="en-US"/>
+              <a:rPr lang="en-US" smtClean="0"/>
               <a:t>Fifth level</a:t>
             </a:r>
+            <a:endParaRPr lang="en-US"/>
           </a:p>
         </p:txBody>
       </p:sp>
@@ -1768,7 +1768,7 @@
           <a:p>
             <a:fld id="{5BCAD085-E8A6-8845-BD4E-CB4CCA059FC4}" type="datetimeFigureOut">
               <a:rPr lang="en-US" smtClean="0"/>
-              <a:t>5/4/26</a:t>
+              <a:t>1/27/13</a:t>
             </a:fld>
             <a:endParaRPr lang="en-US"/>
           </a:p>
@@ -1862,9 +1862,10 @@
           <a:lstStyle/>
           <a:p>
             <a:r>
-              <a:rPr lang="en-US"/>
+              <a:rPr lang="en-US" smtClean="0"/>
               <a:t>Click to edit Master title style</a:t>
             </a:r>
+            <a:endParaRPr lang="en-US"/>
           </a:p>
         </p:txBody>
       </p:sp>
@@ -1885,7 +1886,7 @@
           <a:p>
             <a:fld id="{5BCAD085-E8A6-8845-BD4E-CB4CCA059FC4}" type="datetimeFigureOut">
               <a:rPr lang="en-US" smtClean="0"/>
-              <a:t>5/4/26</a:t>
+              <a:t>1/27/13</a:t>
             </a:fld>
             <a:endParaRPr lang="en-US"/>
           </a:p>
@@ -1980,7 +1981,7 @@
           <a:p>
             <a:fld id="{5BCAD085-E8A6-8845-BD4E-CB4CCA059FC4}" type="datetimeFigureOut">
               <a:rPr lang="en-US" smtClean="0"/>
-              <a:t>5/4/26</a:t>
+              <a:t>1/27/13</a:t>
             </a:fld>
             <a:endParaRPr lang="en-US"/>
           </a:p>
@@ -2083,9 +2084,10 @@
           </a:lstStyle>
           <a:p>
             <a:r>
-              <a:rPr lang="en-US"/>
+              <a:rPr lang="en-US" smtClean="0"/>
               <a:t>Click to edit Master title style</a:t>
             </a:r>
+            <a:endParaRPr lang="en-US"/>
           </a:p>
         </p:txBody>
       </p:sp>
@@ -2139,37 +2141,38 @@
           <a:p>
             <a:pPr lvl="0"/>
             <a:r>
-              <a:rPr lang="en-US"/>
+              <a:rPr lang="en-US" smtClean="0"/>
               <a:t>Click to edit Master text styles</a:t>
             </a:r>
           </a:p>
           <a:p>
             <a:pPr lvl="1"/>
             <a:r>
-              <a:rPr lang="en-US"/>
+              <a:rPr lang="en-US" smtClean="0"/>
               <a:t>Second level</a:t>
             </a:r>
           </a:p>
           <a:p>
             <a:pPr lvl="2"/>
             <a:r>
-              <a:rPr lang="en-US"/>
+              <a:rPr lang="en-US" smtClean="0"/>
               <a:t>Third level</a:t>
             </a:r>
           </a:p>
           <a:p>
             <a:pPr lvl="3"/>
             <a:r>
-              <a:rPr lang="en-US"/>
+              <a:rPr lang="en-US" smtClean="0"/>
               <a:t>Fourth level</a:t>
             </a:r>
           </a:p>
           <a:p>
             <a:pPr lvl="4"/>
             <a:r>
-              <a:rPr lang="en-US"/>
+              <a:rPr lang="en-US" smtClean="0"/>
               <a:t>Fifth level</a:t>
             </a:r>
+            <a:endParaRPr lang="en-US"/>
           </a:p>
         </p:txBody>
       </p:sp>
@@ -2232,7 +2235,7 @@
           <a:p>
             <a:pPr lvl="0"/>
             <a:r>
-              <a:rPr lang="en-US"/>
+              <a:rPr lang="en-US" smtClean="0"/>
               <a:t>Click to edit Master text styles</a:t>
             </a:r>
           </a:p>
@@ -2255,7 +2258,7 @@
           <a:p>
             <a:fld id="{5BCAD085-E8A6-8845-BD4E-CB4CCA059FC4}" type="datetimeFigureOut">
               <a:rPr lang="en-US" smtClean="0"/>
-              <a:t>5/4/26</a:t>
+              <a:t>1/27/13</a:t>
             </a:fld>
             <a:endParaRPr lang="en-US"/>
           </a:p>
@@ -2358,9 +2361,10 @@
           </a:lstStyle>
           <a:p>
             <a:r>
-              <a:rPr lang="en-US"/>
+              <a:rPr lang="en-US" smtClean="0"/>
               <a:t>Click to edit Master title style</a:t>
             </a:r>
+            <a:endParaRPr lang="en-US"/>
           </a:p>
         </p:txBody>
       </p:sp>
@@ -2484,7 +2488,7 @@
           <a:p>
             <a:pPr lvl="0"/>
             <a:r>
-              <a:rPr lang="en-US"/>
+              <a:rPr lang="en-US" smtClean="0"/>
               <a:t>Click to edit Master text styles</a:t>
             </a:r>
           </a:p>
@@ -2507,7 +2511,7 @@
           <a:p>
             <a:fld id="{5BCAD085-E8A6-8845-BD4E-CB4CCA059FC4}" type="datetimeFigureOut">
               <a:rPr lang="en-US" smtClean="0"/>
-              <a:t>5/4/26</a:t>
+              <a:t>1/27/13</a:t>
             </a:fld>
             <a:endParaRPr lang="en-US"/>
           </a:p>
@@ -2616,9 +2620,10 @@
           <a:lstStyle/>
           <a:p>
             <a:r>
-              <a:rPr lang="en-US"/>
+              <a:rPr lang="en-US" smtClean="0"/>
               <a:t>Click to edit Master title style</a:t>
             </a:r>
+            <a:endParaRPr lang="en-US"/>
           </a:p>
         </p:txBody>
       </p:sp>
@@ -2649,37 +2654,38 @@
           <a:p>
             <a:pPr lvl="0"/>
             <a:r>
-              <a:rPr lang="en-US"/>
+              <a:rPr lang="en-US" smtClean="0"/>
               <a:t>Click to edit Master text styles</a:t>
             </a:r>
           </a:p>
           <a:p>
             <a:pPr lvl="1"/>
             <a:r>
-              <a:rPr lang="en-US"/>
+              <a:rPr lang="en-US" smtClean="0"/>
               <a:t>Second level</a:t>
             </a:r>
           </a:p>
           <a:p>
             <a:pPr lvl="2"/>
             <a:r>
-              <a:rPr lang="en-US"/>
+              <a:rPr lang="en-US" smtClean="0"/>
               <a:t>Third level</a:t>
             </a:r>
           </a:p>
           <a:p>
             <a:pPr lvl="3"/>
             <a:r>
-              <a:rPr lang="en-US"/>
+              <a:rPr lang="en-US" smtClean="0"/>
               <a:t>Fourth level</a:t>
             </a:r>
           </a:p>
           <a:p>
             <a:pPr lvl="4"/>
             <a:r>
-              <a:rPr lang="en-US"/>
+              <a:rPr lang="en-US" smtClean="0"/>
               <a:t>Fifth level</a:t>
             </a:r>
+            <a:endParaRPr lang="en-US"/>
           </a:p>
         </p:txBody>
       </p:sp>
@@ -2718,7 +2724,7 @@
           <a:p>
             <a:fld id="{5BCAD085-E8A6-8845-BD4E-CB4CCA059FC4}" type="datetimeFigureOut">
               <a:rPr lang="en-US" smtClean="0"/>
-              <a:t>5/4/26</a:t>
+              <a:t>1/27/13</a:t>
             </a:fld>
             <a:endParaRPr lang="en-US"/>
           </a:p>
@@ -3077,7 +3083,7 @@
 </file>
 
 <file path=ppt/slides/slide1.xml><?xml version="1.0" encoding="utf-8"?>
-<p:sld xmlns:a="http://schemas.openxmlformats.org/drawingml/2006/main" xmlns:r="http://schemas.openxmlformats.org/officeDocument/2006/relationships" xmlns:p="http://schemas.openxmlformats.org/presentationml/2006/main">
+<p:sld xmlns:a="http://schemas.openxmlformats.org/drawingml/2006/main" xmlns:p="http://schemas.openxmlformats.org/presentationml/2006/main" xmlns:r="http://schemas.openxmlformats.org/officeDocument/2006/relationships">
   <p:cSld>
     <p:bg>
       <p:bgPr>
@@ -3093,14 +3099,7 @@
         <p:cNvGrpSpPr/>
         <p:nvPr/>
       </p:nvGrpSpPr>
-      <p:grpSpPr>
-        <a:xfrm>
-          <a:off x="0" y="0"/>
-          <a:ext cx="0" cy="0"/>
-          <a:chOff x="0" y="0"/>
-          <a:chExt cx="0" cy="0"/>
-        </a:xfrm>
-      </p:grpSpPr>
+      <p:grpSpPr/>
       <p:sp>
         <p:nvSpPr>
           <p:cNvPr id="2" name="Rectangle 1"/>
@@ -3142,7 +3141,6 @@
           <a:lstStyle/>
           <a:p>
             <a:pPr algn="ctr"/>
-            <a:endParaRPr/>
           </a:p>
         </p:txBody>
       </p:sp>
@@ -3163,7 +3161,7 @@
           <a:noFill/>
         </p:spPr>
         <p:txBody>
-          <a:bodyPr wrap="square" lIns="0" tIns="0" rIns="0" bIns="0" anchor="t">
+          <a:bodyPr wrap="square" lIns="0" rIns="0" tIns="0" bIns="0" anchor="t">
             <a:spAutoFit/>
           </a:bodyPr>
           <a:lstStyle/>
@@ -3194,7 +3192,7 @@
         <p:spPr>
           <a:xfrm>
             <a:off x="795528" y="2468880"/>
-            <a:ext cx="9262872" cy="837217"/>
+            <a:ext cx="9262872" cy="1828800"/>
           </a:xfrm>
           <a:prstGeom prst="rect">
             <a:avLst/>
@@ -3202,7 +3200,7 @@
           <a:noFill/>
         </p:spPr>
         <p:txBody>
-          <a:bodyPr wrap="square" lIns="0" tIns="0" rIns="0" bIns="0" anchor="t">
+          <a:bodyPr wrap="square" lIns="0" rIns="0" tIns="0" bIns="0" anchor="t">
             <a:spAutoFit/>
           </a:bodyPr>
           <a:lstStyle/>
@@ -3213,27 +3211,27 @@
               </a:lnSpc>
             </a:pPr>
             <a:r>
-              <a:rPr sz="5400" b="1" i="0" dirty="0">
+              <a:rPr sz="5400" b="1" i="0">
                 <a:solidFill>
                   <a:srgbClr val="030303"/>
                 </a:solidFill>
                 <a:latin typeface="Petrona"/>
               </a:rPr>
-              <a:t>Closing Out a Project</a:t>
-            </a:r>
-          </a:p>
-        </p:txBody>
-      </p:sp>
-      <p:sp>
-        <p:nvSpPr>
-          <p:cNvPr id="6" name="TextBox 5"/>
+              <a:t>Closing Out a Messy Project</a:t>
+            </a:r>
+          </a:p>
+        </p:txBody>
+      </p:sp>
+      <p:sp>
+        <p:nvSpPr>
+          <p:cNvPr id="5" name="TextBox 4"/>
           <p:cNvSpPr txBox="1"/>
           <p:nvPr/>
         </p:nvSpPr>
         <p:spPr>
           <a:xfrm>
-            <a:off x="795528" y="7406640"/>
-            <a:ext cx="5486400" cy="365760"/>
+            <a:off x="795528" y="4754880"/>
+            <a:ext cx="9262872" cy="1371600"/>
           </a:xfrm>
           <a:prstGeom prst="rect">
             <a:avLst/>
@@ -3241,7 +3239,46 @@
           <a:noFill/>
         </p:spPr>
         <p:txBody>
-          <a:bodyPr wrap="square" lIns="0" tIns="0" rIns="0" bIns="0" anchor="t">
+          <a:bodyPr wrap="square" lIns="0" rIns="0" tIns="0" bIns="0" anchor="t">
+            <a:spAutoFit/>
+          </a:bodyPr>
+          <a:lstStyle/>
+          <a:p>
+            <a:pPr algn="l">
+              <a:lnSpc>
+                <a:spcPct val="125000"/>
+              </a:lnSpc>
+            </a:pPr>
+            <a:r>
+              <a:rPr sz="2200" b="0" i="0">
+                <a:solidFill>
+                  <a:srgbClr val="272525"/>
+                </a:solidFill>
+                <a:latin typeface="Inter"/>
+              </a:rPr>
+              <a:t>Seven files. Three deliverables. One afternoon.</a:t>
+            </a:r>
+          </a:p>
+        </p:txBody>
+      </p:sp>
+      <p:sp>
+        <p:nvSpPr>
+          <p:cNvPr id="6" name="TextBox 5"/>
+          <p:cNvSpPr txBox="1"/>
+          <p:nvPr/>
+        </p:nvSpPr>
+        <p:spPr>
+          <a:xfrm>
+            <a:off x="795528" y="7406640"/>
+            <a:ext cx="5486400" cy="365760"/>
+          </a:xfrm>
+          <a:prstGeom prst="rect">
+            <a:avLst/>
+          </a:prstGeom>
+          <a:noFill/>
+        </p:spPr>
+        <p:txBody>
+          <a:bodyPr wrap="square" lIns="0" rIns="0" tIns="0" bIns="0" anchor="t">
             <a:spAutoFit/>
           </a:bodyPr>
           <a:lstStyle/>
@@ -3272,7 +3309,7 @@
 </file>
 
 <file path=ppt/slides/slide2.xml><?xml version="1.0" encoding="utf-8"?>
-<p:sld xmlns:a="http://schemas.openxmlformats.org/drawingml/2006/main" xmlns:r="http://schemas.openxmlformats.org/officeDocument/2006/relationships" xmlns:p="http://schemas.openxmlformats.org/presentationml/2006/main">
+<p:sld xmlns:a="http://schemas.openxmlformats.org/drawingml/2006/main" xmlns:p="http://schemas.openxmlformats.org/presentationml/2006/main" xmlns:r="http://schemas.openxmlformats.org/officeDocument/2006/relationships">
   <p:cSld>
     <p:bg>
       <p:bgPr>
@@ -3288,24 +3325,17 @@
         <p:cNvGrpSpPr/>
         <p:nvPr/>
       </p:nvGrpSpPr>
-      <p:grpSpPr>
-        <a:xfrm>
-          <a:off x="0" y="0"/>
-          <a:ext cx="0" cy="0"/>
-          <a:chOff x="0" y="0"/>
-          <a:chExt cx="0" cy="0"/>
-        </a:xfrm>
-      </p:grpSpPr>
-      <p:sp>
-        <p:nvSpPr>
-          <p:cNvPr id="3" name="TextBox 2"/>
+      <p:grpSpPr/>
+      <p:sp>
+        <p:nvSpPr>
+          <p:cNvPr id="2" name="TextBox 1"/>
           <p:cNvSpPr txBox="1"/>
           <p:nvPr/>
         </p:nvSpPr>
         <p:spPr>
           <a:xfrm>
-            <a:off x="795528" y="1280160"/>
-            <a:ext cx="9262872" cy="675441"/>
+            <a:off x="795528" y="822960"/>
+            <a:ext cx="9262872" cy="365760"/>
           </a:xfrm>
           <a:prstGeom prst="rect">
             <a:avLst/>
@@ -3313,7 +3343,46 @@
           <a:noFill/>
         </p:spPr>
         <p:txBody>
-          <a:bodyPr wrap="square" lIns="0" tIns="0" rIns="0" bIns="0" anchor="t">
+          <a:bodyPr wrap="square" lIns="0" rIns="0" tIns="0" bIns="0" anchor="t">
+            <a:spAutoFit/>
+          </a:bodyPr>
+          <a:lstStyle/>
+          <a:p>
+            <a:pPr algn="l">
+              <a:lnSpc>
+                <a:spcPct val="115000"/>
+              </a:lnSpc>
+            </a:pPr>
+            <a:r>
+              <a:rPr sz="1200" b="1" i="0">
+                <a:solidFill>
+                  <a:srgbClr val="2B6E2B"/>
+                </a:solidFill>
+                <a:latin typeface="Inter"/>
+              </a:rPr>
+              <a:t>THE IPC LYDON BUNDLE</a:t>
+            </a:r>
+          </a:p>
+        </p:txBody>
+      </p:sp>
+      <p:sp>
+        <p:nvSpPr>
+          <p:cNvPr id="3" name="TextBox 2"/>
+          <p:cNvSpPr txBox="1"/>
+          <p:nvPr/>
+        </p:nvSpPr>
+        <p:spPr>
+          <a:xfrm>
+            <a:off x="795528" y="1280160"/>
+            <a:ext cx="9262872" cy="1463040"/>
+          </a:xfrm>
+          <a:prstGeom prst="rect">
+            <a:avLst/>
+          </a:prstGeom>
+          <a:noFill/>
+        </p:spPr>
+        <p:txBody>
+          <a:bodyPr wrap="square" lIns="0" rIns="0" tIns="0" bIns="0" anchor="t">
             <a:spAutoFit/>
           </a:bodyPr>
           <a:lstStyle/>
@@ -3324,13 +3393,13 @@
               </a:lnSpc>
             </a:pPr>
             <a:r>
-              <a:rPr sz="4200" b="1" i="0" dirty="0">
+              <a:rPr sz="4200" b="1" i="0">
                 <a:solidFill>
                   <a:srgbClr val="030303"/>
                 </a:solidFill>
                 <a:latin typeface="Petrona"/>
               </a:rPr>
-              <a:t>What you have. </a:t>
+              <a:t>What you have. What you owe.</a:t>
             </a:r>
           </a:p>
         </p:txBody>
@@ -3376,7 +3445,6 @@
           <a:lstStyle/>
           <a:p>
             <a:pPr algn="ctr"/>
-            <a:endParaRPr/>
           </a:p>
         </p:txBody>
       </p:sp>
@@ -3397,7 +3465,7 @@
           <a:noFill/>
         </p:spPr>
         <p:txBody>
-          <a:bodyPr wrap="square" lIns="0" tIns="0" rIns="0" bIns="0" anchor="t">
+          <a:bodyPr wrap="square" lIns="0" rIns="0" tIns="0" bIns="0" anchor="t">
             <a:spAutoFit/>
           </a:bodyPr>
           <a:lstStyle/>
@@ -3460,7 +3528,7 @@
 </file>
 
 <file path=ppt/slides/slide3.xml><?xml version="1.0" encoding="utf-8"?>
-<p:sld xmlns:a="http://schemas.openxmlformats.org/drawingml/2006/main" xmlns:r="http://schemas.openxmlformats.org/officeDocument/2006/relationships" xmlns:p="http://schemas.openxmlformats.org/presentationml/2006/main">
+<p:sld xmlns:a="http://schemas.openxmlformats.org/drawingml/2006/main" xmlns:p="http://schemas.openxmlformats.org/presentationml/2006/main" xmlns:r="http://schemas.openxmlformats.org/officeDocument/2006/relationships">
   <p:cSld>
     <p:bg>
       <p:bgPr>
@@ -3476,14 +3544,7 @@
         <p:cNvGrpSpPr/>
         <p:nvPr/>
       </p:nvGrpSpPr>
-      <p:grpSpPr>
-        <a:xfrm>
-          <a:off x="0" y="0"/>
-          <a:ext cx="0" cy="0"/>
-          <a:chOff x="0" y="0"/>
-          <a:chExt cx="0" cy="0"/>
-        </a:xfrm>
-      </p:grpSpPr>
+      <p:grpSpPr/>
       <p:sp>
         <p:nvSpPr>
           <p:cNvPr id="2" name="TextBox 1"/>
@@ -3501,7 +3562,7 @@
           <a:noFill/>
         </p:spPr>
         <p:txBody>
-          <a:bodyPr wrap="square" lIns="0" tIns="0" rIns="0" bIns="0" anchor="t">
+          <a:bodyPr wrap="square" lIns="0" rIns="0" tIns="0" bIns="0" anchor="t">
             <a:spAutoFit/>
           </a:bodyPr>
           <a:lstStyle/>
@@ -3532,7 +3593,7 @@
         <p:spPr>
           <a:xfrm>
             <a:off x="795528" y="1051560"/>
-            <a:ext cx="9262872" cy="465127"/>
+            <a:ext cx="9262872" cy="1005840"/>
           </a:xfrm>
           <a:prstGeom prst="rect">
             <a:avLst/>
@@ -3540,7 +3601,7 @@
           <a:noFill/>
         </p:spPr>
         <p:txBody>
-          <a:bodyPr wrap="square" lIns="0" tIns="0" rIns="0" bIns="0" anchor="t">
+          <a:bodyPr wrap="square" lIns="0" rIns="0" tIns="0" bIns="0" anchor="t">
             <a:spAutoFit/>
           </a:bodyPr>
           <a:lstStyle/>
@@ -3551,13 +3612,13 @@
               </a:lnSpc>
             </a:pPr>
             <a:r>
-              <a:rPr sz="3000" b="1" i="0" dirty="0">
+              <a:rPr sz="3000" b="1" i="0">
                 <a:solidFill>
                   <a:srgbClr val="030303"/>
                 </a:solidFill>
                 <a:latin typeface="Petrona"/>
               </a:rPr>
-              <a:t>Ask one focused question.</a:t>
+              <a:t>Drop the zip. Ask one focused question.</a:t>
             </a:r>
           </a:p>
         </p:txBody>
@@ -3603,7 +3664,6 @@
           <a:lstStyle/>
           <a:p>
             <a:pPr algn="ctr"/>
-            <a:endParaRPr/>
           </a:p>
         </p:txBody>
       </p:sp>
@@ -3648,7 +3708,6 @@
           <a:lstStyle/>
           <a:p>
             <a:pPr algn="ctr"/>
-            <a:endParaRPr/>
           </a:p>
         </p:txBody>
       </p:sp>
@@ -3693,7 +3752,7 @@
           <a:noFill/>
         </p:spPr>
         <p:txBody>
-          <a:bodyPr wrap="square" lIns="0" tIns="0" rIns="0" bIns="0" anchor="t">
+          <a:bodyPr wrap="square" lIns="0" rIns="0" tIns="0" bIns="0" anchor="t">
             <a:spAutoFit/>
           </a:bodyPr>
           <a:lstStyle/>
@@ -3724,7 +3783,7 @@
 </file>
 
 <file path=ppt/slides/slide4.xml><?xml version="1.0" encoding="utf-8"?>
-<p:sld xmlns:a="http://schemas.openxmlformats.org/drawingml/2006/main" xmlns:r="http://schemas.openxmlformats.org/officeDocument/2006/relationships" xmlns:p="http://schemas.openxmlformats.org/presentationml/2006/main">
+<p:sld xmlns:a="http://schemas.openxmlformats.org/drawingml/2006/main" xmlns:p="http://schemas.openxmlformats.org/presentationml/2006/main" xmlns:r="http://schemas.openxmlformats.org/officeDocument/2006/relationships">
   <p:cSld>
     <p:bg>
       <p:bgPr>
@@ -3740,14 +3799,7 @@
         <p:cNvGrpSpPr/>
         <p:nvPr/>
       </p:nvGrpSpPr>
-      <p:grpSpPr>
-        <a:xfrm>
-          <a:off x="0" y="0"/>
-          <a:ext cx="0" cy="0"/>
-          <a:chOff x="0" y="0"/>
-          <a:chExt cx="0" cy="0"/>
-        </a:xfrm>
-      </p:grpSpPr>
+      <p:grpSpPr/>
       <p:sp>
         <p:nvSpPr>
           <p:cNvPr id="2" name="TextBox 1"/>
@@ -3765,7 +3817,7 @@
           <a:noFill/>
         </p:spPr>
         <p:txBody>
-          <a:bodyPr wrap="square" lIns="0" tIns="0" rIns="0" bIns="0" anchor="t">
+          <a:bodyPr wrap="square" lIns="0" rIns="0" tIns="0" bIns="0" anchor="t">
             <a:spAutoFit/>
           </a:bodyPr>
           <a:lstStyle/>
@@ -3796,7 +3848,7 @@
         <p:spPr>
           <a:xfrm>
             <a:off x="795528" y="1051560"/>
-            <a:ext cx="9262872" cy="465127"/>
+            <a:ext cx="9262872" cy="1005840"/>
           </a:xfrm>
           <a:prstGeom prst="rect">
             <a:avLst/>
@@ -3804,7 +3856,7 @@
           <a:noFill/>
         </p:spPr>
         <p:txBody>
-          <a:bodyPr wrap="square" lIns="0" tIns="0" rIns="0" bIns="0" anchor="t">
+          <a:bodyPr wrap="square" lIns="0" rIns="0" tIns="0" bIns="0" anchor="t">
             <a:spAutoFit/>
           </a:bodyPr>
           <a:lstStyle/>
@@ -3815,13 +3867,13 @@
               </a:lnSpc>
             </a:pPr>
             <a:r>
-              <a:rPr sz="3000" b="1" i="0" dirty="0">
+              <a:rPr sz="3000" b="1" i="0">
                 <a:solidFill>
                   <a:srgbClr val="030303"/>
                 </a:solidFill>
                 <a:latin typeface="Petrona"/>
               </a:rPr>
-              <a:t>Same approach. </a:t>
+              <a:t>Same approach. On-prem.</a:t>
             </a:r>
           </a:p>
         </p:txBody>
@@ -3867,7 +3919,6 @@
           <a:lstStyle/>
           <a:p>
             <a:pPr algn="ctr"/>
-            <a:endParaRPr/>
           </a:p>
         </p:txBody>
       </p:sp>
@@ -3912,7 +3963,6 @@
           <a:lstStyle/>
           <a:p>
             <a:pPr algn="ctr"/>
-            <a:endParaRPr/>
           </a:p>
         </p:txBody>
       </p:sp>
@@ -3957,7 +4007,7 @@
           <a:noFill/>
         </p:spPr>
         <p:txBody>
-          <a:bodyPr wrap="square" lIns="0" tIns="0" rIns="0" bIns="0" anchor="t">
+          <a:bodyPr wrap="square" lIns="0" rIns="0" tIns="0" bIns="0" anchor="t">
             <a:spAutoFit/>
           </a:bodyPr>
           <a:lstStyle/>
@@ -3968,13 +4018,260 @@
               </a:lnSpc>
             </a:pPr>
             <a:r>
-              <a:rPr sz="1400" b="0" i="1" dirty="0">
+              <a:rPr sz="1400" b="0" i="1">
                 <a:solidFill>
                   <a:srgbClr val="6B6B6B"/>
                 </a:solidFill>
                 <a:latin typeface="Inter"/>
               </a:rPr>
               <a:t>For real Cashman files, attach to the Portal instead. Files stay on company infrastructure. Best paired with Microsoft Copilot inside Word/Excel for per-file follow-ups.</a:t>
+            </a:r>
+          </a:p>
+        </p:txBody>
+      </p:sp>
+    </p:spTree>
+  </p:cSld>
+  <p:clrMapOvr>
+    <a:masterClrMapping/>
+  </p:clrMapOvr>
+</p:sld>
+</file>
+
+<file path=ppt/slides/slide5.xml><?xml version="1.0" encoding="utf-8"?>
+<p:sld xmlns:a="http://schemas.openxmlformats.org/drawingml/2006/main" xmlns:p="http://schemas.openxmlformats.org/presentationml/2006/main" xmlns:r="http://schemas.openxmlformats.org/officeDocument/2006/relationships">
+  <p:cSld>
+    <p:bg>
+      <p:bgPr>
+        <a:solidFill>
+          <a:srgbClr val="FDFAF7"/>
+        </a:solidFill>
+        <a:effectLst/>
+      </p:bgPr>
+    </p:bg>
+    <p:spTree>
+      <p:nvGrpSpPr>
+        <p:cNvPr id="1" name=""/>
+        <p:cNvGrpSpPr/>
+        <p:nvPr/>
+      </p:nvGrpSpPr>
+      <p:grpSpPr/>
+      <p:sp>
+        <p:nvSpPr>
+          <p:cNvPr id="2" name="TextBox 1"/>
+          <p:cNvSpPr txBox="1"/>
+          <p:nvPr/>
+        </p:nvSpPr>
+        <p:spPr>
+          <a:xfrm>
+            <a:off x="795528" y="822960"/>
+            <a:ext cx="9262872" cy="365760"/>
+          </a:xfrm>
+          <a:prstGeom prst="rect">
+            <a:avLst/>
+          </a:prstGeom>
+          <a:noFill/>
+        </p:spPr>
+        <p:txBody>
+          <a:bodyPr wrap="square" lIns="0" rIns="0" tIns="0" bIns="0" anchor="t">
+            <a:spAutoFit/>
+          </a:bodyPr>
+          <a:lstStyle/>
+          <a:p>
+            <a:pPr algn="l">
+              <a:lnSpc>
+                <a:spcPct val="115000"/>
+              </a:lnSpc>
+            </a:pPr>
+            <a:r>
+              <a:rPr sz="1200" b="1" i="0">
+                <a:solidFill>
+                  <a:srgbClr val="2B6E2B"/>
+                </a:solidFill>
+                <a:latin typeface="Inter"/>
+              </a:rPr>
+              <a:t>THE AUDIT TRAIL</a:t>
+            </a:r>
+          </a:p>
+        </p:txBody>
+      </p:sp>
+      <p:sp>
+        <p:nvSpPr>
+          <p:cNvPr id="3" name="TextBox 2"/>
+          <p:cNvSpPr txBox="1"/>
+          <p:nvPr/>
+        </p:nvSpPr>
+        <p:spPr>
+          <a:xfrm>
+            <a:off x="795528" y="1280160"/>
+            <a:ext cx="9262872" cy="1828800"/>
+          </a:xfrm>
+          <a:prstGeom prst="rect">
+            <a:avLst/>
+          </a:prstGeom>
+          <a:noFill/>
+        </p:spPr>
+        <p:txBody>
+          <a:bodyPr wrap="square" lIns="0" rIns="0" tIns="0" bIns="0" anchor="t">
+            <a:spAutoFit/>
+          </a:bodyPr>
+          <a:lstStyle/>
+          <a:p>
+            <a:pPr algn="l">
+              <a:lnSpc>
+                <a:spcPct val="110000"/>
+              </a:lnSpc>
+            </a:pPr>
+            <a:r>
+              <a:rPr sz="4200" b="1" i="0">
+                <a:solidFill>
+                  <a:srgbClr val="030303"/>
+                </a:solidFill>
+                <a:latin typeface="Petrona"/>
+              </a:rPr>
+              <a:t>AI is the typist. You are the auditor.</a:t>
+            </a:r>
+          </a:p>
+        </p:txBody>
+      </p:sp>
+      <p:sp>
+        <p:nvSpPr>
+          <p:cNvPr id="4" name="Rectangle 3"/>
+          <p:cNvSpPr/>
+          <p:nvPr/>
+        </p:nvSpPr>
+        <p:spPr>
+          <a:xfrm>
+            <a:off x="795528" y="3840480"/>
+            <a:ext cx="9262872" cy="2377440"/>
+          </a:xfrm>
+          <a:prstGeom prst="rect">
+            <a:avLst/>
+          </a:prstGeom>
+          <a:solidFill>
+            <a:srgbClr val="C8E9C8"/>
+          </a:solidFill>
+          <a:ln>
+            <a:noFill/>
+          </a:ln>
+          <a:effectLst/>
+        </p:spPr>
+        <p:style>
+          <a:lnRef idx="1">
+            <a:schemeClr val="accent1"/>
+          </a:lnRef>
+          <a:fillRef idx="3">
+            <a:schemeClr val="accent1"/>
+          </a:fillRef>
+          <a:effectRef idx="2">
+            <a:schemeClr val="accent1"/>
+          </a:effectRef>
+          <a:fontRef idx="minor">
+            <a:schemeClr val="lt1"/>
+          </a:fontRef>
+        </p:style>
+        <p:txBody>
+          <a:bodyPr rtlCol="0" anchor="ctr"/>
+          <a:lstStyle/>
+          <a:p>
+            <a:pPr algn="ctr"/>
+          </a:p>
+        </p:txBody>
+      </p:sp>
+      <p:sp>
+        <p:nvSpPr>
+          <p:cNvPr id="5" name="Rectangle 4"/>
+          <p:cNvSpPr/>
+          <p:nvPr/>
+        </p:nvSpPr>
+        <p:spPr>
+          <a:xfrm>
+            <a:off x="758952" y="3840480"/>
+            <a:ext cx="118872" cy="2377440"/>
+          </a:xfrm>
+          <a:prstGeom prst="rect">
+            <a:avLst/>
+          </a:prstGeom>
+          <a:solidFill>
+            <a:srgbClr val="2B6E2B"/>
+          </a:solidFill>
+          <a:ln>
+            <a:noFill/>
+          </a:ln>
+          <a:effectLst/>
+        </p:spPr>
+        <p:style>
+          <a:lnRef idx="1">
+            <a:schemeClr val="accent1"/>
+          </a:lnRef>
+          <a:fillRef idx="3">
+            <a:schemeClr val="accent1"/>
+          </a:fillRef>
+          <a:effectRef idx="2">
+            <a:schemeClr val="accent1"/>
+          </a:effectRef>
+          <a:fontRef idx="minor">
+            <a:schemeClr val="lt1"/>
+          </a:fontRef>
+        </p:style>
+        <p:txBody>
+          <a:bodyPr rtlCol="0" anchor="ctr"/>
+          <a:lstStyle/>
+          <a:p>
+            <a:pPr algn="ctr"/>
+          </a:p>
+        </p:txBody>
+      </p:sp>
+      <p:sp>
+        <p:nvSpPr>
+          <p:cNvPr id="6" name="TextBox 5"/>
+          <p:cNvSpPr txBox="1"/>
+          <p:nvPr/>
+        </p:nvSpPr>
+        <p:spPr>
+          <a:xfrm>
+            <a:off x="1161288" y="4160520"/>
+            <a:ext cx="8531352" cy="1737360"/>
+          </a:xfrm>
+          <a:prstGeom prst="rect">
+            <a:avLst/>
+          </a:prstGeom>
+          <a:noFill/>
+        </p:spPr>
+        <p:txBody>
+          <a:bodyPr wrap="square" lIns="0" rIns="0" tIns="0" bIns="0" anchor="ctr">
+            <a:spAutoFit/>
+          </a:bodyPr>
+          <a:lstStyle/>
+          <a:p>
+            <a:pPr algn="l">
+              <a:lnSpc>
+                <a:spcPct val="125000"/>
+              </a:lnSpc>
+            </a:pPr>
+            <a:r>
+              <a:rPr sz="2600" b="1" i="0">
+                <a:solidFill>
+                  <a:srgbClr val="030303"/>
+                </a:solidFill>
+                <a:latin typeface="Petrona"/>
+              </a:rPr>
+              <a:t>Every dollar in your timeline must tie to cost-tracking.xlsx.</a:t>
+            </a:r>
+          </a:p>
+          <a:p>
+            <a:pPr algn="l">
+              <a:lnSpc>
+                <a:spcPct val="125000"/>
+              </a:lnSpc>
+            </a:pPr>
+            <a:r>
+              <a:rPr sz="2600" b="1" i="0">
+                <a:solidFill>
+                  <a:srgbClr val="030303"/>
+                </a:solidFill>
+                <a:latin typeface="Petrona"/>
+              </a:rPr>
+              <a:t>Dates chronological. No invented quotes.</a:t>
             </a:r>
           </a:p>
         </p:txBody>

</xml_diff>